<commit_message>
Restore slides 4 & 9 on cream, declutter slide 7
Adjust the existing deck without rebuilding it or losing content:

- Slides 4 ("Un outil à double tranchant") and 9 ("Histoire vraie · 2023")
  are restored to their original cream-background parts with full content
  (2-column opportunité/risque; the three narrative beats). The navy
  background is now reserved to the "Les règles du jeu" divider (10) and the
  "Vos questions" closing (23) only. Slide 9's opening quote mark is set to
  full terracotta.
- Slide 7 ("Le contexte, c'est la clé") decluttered: the third "outil
  généraliste" cluster is removed, leaving an airy two-column Sans/Avec
  contexte contrast plus the closing methodology callout.

Typography stays Arial to preserve the existing DA across all slides.

Co-Authored-By: Claude Opus 4.8 <noreply@anthropic.com>
Claude-Session: https://claude.ai/code/session_01LnTzG8UnNia6tSUwKBP69F
</commit_message>
<xml_diff>
--- a/Demande_de_prompt_formation_IA_2.pptx
+++ b/Demande_de_prompt_formation_IA_2.pptx
@@ -14570,7 +14570,7 @@
     <p:bg>
       <p:bgPr>
         <a:solidFill>
-          <a:srgbClr val="14304A"/>
+          <a:srgbClr val="F7F2EA"/>
         </a:solidFill>
         <a:effectLst/>
       </p:bgPr>
@@ -14591,14 +14591,14 @@
       </p:grpSpPr>
       <p:sp>
         <p:nvSpPr>
-          <p:cNvPr id="2" name="Rectangle 1"/>
-          <p:cNvSpPr/>
-          <p:nvPr/>
-        </p:nvSpPr>
-        <p:spPr>
-          <a:xfrm>
-            <a:off x="1143000" y="1042415"/>
-            <a:ext cx="457200" cy="36576"/>
+          <p:cNvPr id="2" name="Shape 0"/>
+          <p:cNvSpPr/>
+          <p:nvPr/>
+        </p:nvSpPr>
+        <p:spPr>
+          <a:xfrm>
+            <a:off x="1143000" y="1038225"/>
+            <a:ext cx="381000" cy="19050"/>
           </a:xfrm>
           <a:prstGeom prst="rect">
             <a:avLst/>
@@ -14606,175 +14606,943 @@
           <a:solidFill>
             <a:srgbClr val="C0623F"/>
           </a:solidFill>
-          <a:ln>
-            <a:noFill/>
-          </a:ln>
-        </p:spPr>
-        <p:style>
-          <a:lnRef idx="1">
-            <a:schemeClr val="accent1"/>
-          </a:lnRef>
-          <a:fillRef idx="3">
-            <a:schemeClr val="accent1"/>
-          </a:fillRef>
-          <a:effectRef idx="2">
-            <a:schemeClr val="accent1"/>
-          </a:effectRef>
-          <a:fontRef idx="minor">
-            <a:schemeClr val="lt1"/>
-          </a:fontRef>
-        </p:style>
-        <p:txBody>
-          <a:bodyPr rtlCol="0" anchor="ctr"/>
-          <a:lstStyle/>
-          <a:p>
-            <a:pPr algn="ctr"/>
-          </a:p>
-        </p:txBody>
-      </p:sp>
-      <p:sp>
-        <p:nvSpPr>
-          <p:cNvPr id="3" name="TextBox 2"/>
-          <p:cNvSpPr txBox="1"/>
-          <p:nvPr/>
-        </p:nvSpPr>
-        <p:spPr>
-          <a:xfrm>
-            <a:off x="1737360" y="868680"/>
-            <a:ext cx="9144000" cy="365760"/>
-          </a:xfrm>
-          <a:prstGeom prst="rect">
-            <a:avLst/>
-          </a:prstGeom>
-          <a:noFill/>
-        </p:spPr>
-        <p:txBody>
-          <a:bodyPr wrap="none">
-            <a:spAutoFit/>
-          </a:bodyPr>
-          <a:lstStyle/>
-          <a:p>
-            <a:r>
-              <a:rPr sz="1600" b="1">
+          <a:ln/>
+        </p:spPr>
+      </p:sp>
+      <p:sp>
+        <p:nvSpPr>
+          <p:cNvPr id="3" name="Text 1"/>
+          <p:cNvSpPr/>
+          <p:nvPr/>
+        </p:nvSpPr>
+        <p:spPr>
+          <a:xfrm>
+            <a:off x="1676400" y="914400"/>
+            <a:ext cx="4093756" cy="304800"/>
+          </a:xfrm>
+          <a:prstGeom prst="rect">
+            <a:avLst/>
+          </a:prstGeom>
+          <a:noFill/>
+          <a:ln/>
+        </p:spPr>
+        <p:txBody>
+          <a:bodyPr wrap="square" lIns="25400" tIns="25400" rIns="25400" bIns="25400" rtlCol="0" anchor="t">
+            <a:normAutofit lnSpcReduction="10000"/>
+          </a:bodyPr>
+          <a:lstStyle/>
+          <a:p>
+            <a:pPr marL="0" indent="0" algn="l">
+              <a:buNone/>
+            </a:pPr>
+            <a:r>
+              <a:rPr lang="en-US" sz="1800" b="1" kern="0" spc="300" dirty="0">
+                <a:solidFill>
+                  <a:srgbClr val="5B6B79"/>
+                </a:solidFill>
+                <a:latin typeface="Arial" pitchFamily="34" charset="0"/>
+                <a:ea typeface="Arial" pitchFamily="34" charset="-122"/>
+                <a:cs typeface="Arial" pitchFamily="34" charset="-120"/>
+              </a:rPr>
+              <a:t>SÉQUENCE 0 · POURQUOI</a:t>
+            </a:r>
+            <a:endParaRPr lang="en-US" sz="1800" dirty="0"/>
+          </a:p>
+        </p:txBody>
+      </p:sp>
+      <p:sp>
+        <p:nvSpPr>
+          <p:cNvPr id="4" name="Text 2"/>
+          <p:cNvSpPr/>
+          <p:nvPr/>
+        </p:nvSpPr>
+        <p:spPr>
+          <a:xfrm>
+            <a:off x="1143000" y="1390650"/>
+            <a:ext cx="17602200" cy="790873"/>
+          </a:xfrm>
+          <a:prstGeom prst="rect">
+            <a:avLst/>
+          </a:prstGeom>
+          <a:noFill/>
+          <a:ln/>
+        </p:spPr>
+        <p:txBody>
+          <a:bodyPr wrap="square" lIns="25400" tIns="25400" rIns="25400" bIns="25400" rtlCol="0" anchor="t">
+            <a:normAutofit fontScale="92500" lnSpcReduction="20000"/>
+          </a:bodyPr>
+          <a:lstStyle/>
+          <a:p>
+            <a:pPr marL="0" indent="0" algn="l">
+              <a:lnSpc>
+                <a:spcPct val="104000"/>
+              </a:lnSpc>
+              <a:buNone/>
+            </a:pPr>
+            <a:r>
+              <a:rPr lang="en-US" sz="5700" b="1" kern="0" spc="-112" dirty="0">
+                <a:solidFill>
+                  <a:srgbClr val="14304A"/>
+                </a:solidFill>
+                <a:latin typeface="Arial" pitchFamily="34" charset="0"/>
+                <a:ea typeface="Arial" pitchFamily="34" charset="-122"/>
+                <a:cs typeface="Arial" pitchFamily="34" charset="-120"/>
+              </a:rPr>
+              <a:t>Un outil à double tranchant</a:t>
+            </a:r>
+            <a:endParaRPr lang="en-US" sz="5700" dirty="0"/>
+          </a:p>
+        </p:txBody>
+      </p:sp>
+      <p:sp>
+        <p:nvSpPr>
+          <p:cNvPr id="5" name="Shape 3"/>
+          <p:cNvSpPr/>
+          <p:nvPr/>
+        </p:nvSpPr>
+        <p:spPr>
+          <a:xfrm>
+            <a:off x="1143000" y="2562523"/>
+            <a:ext cx="7839075" cy="3196233"/>
+          </a:xfrm>
+          <a:prstGeom prst="roundRect">
+            <a:avLst>
+              <a:gd name="adj" fmla="val 4172"/>
+            </a:avLst>
+          </a:prstGeom>
+          <a:solidFill>
+            <a:srgbClr val="FFFFFF"/>
+          </a:solidFill>
+          <a:ln/>
+        </p:spPr>
+      </p:sp>
+      <p:sp>
+        <p:nvSpPr>
+          <p:cNvPr id="6" name="Shape 4"/>
+          <p:cNvSpPr/>
+          <p:nvPr/>
+        </p:nvSpPr>
+        <p:spPr>
+          <a:xfrm>
+            <a:off x="1143000" y="5749230"/>
+            <a:ext cx="7839075" cy="9525"/>
+          </a:xfrm>
+          <a:prstGeom prst="rect">
+            <a:avLst/>
+          </a:prstGeom>
+          <a:solidFill>
+            <a:srgbClr val="D5DBDF"/>
+          </a:solidFill>
+          <a:ln/>
+        </p:spPr>
+      </p:sp>
+      <p:sp>
+        <p:nvSpPr>
+          <p:cNvPr id="7" name="Shape 5"/>
+          <p:cNvSpPr/>
+          <p:nvPr/>
+        </p:nvSpPr>
+        <p:spPr>
+          <a:xfrm>
+            <a:off x="1143000" y="2562523"/>
+            <a:ext cx="7839075" cy="57150"/>
+          </a:xfrm>
+          <a:prstGeom prst="rect">
+            <a:avLst/>
+          </a:prstGeom>
+          <a:solidFill>
+            <a:srgbClr val="14304A"/>
+          </a:solidFill>
+          <a:ln/>
+        </p:spPr>
+      </p:sp>
+      <p:sp>
+        <p:nvSpPr>
+          <p:cNvPr id="8" name="Shape 6"/>
+          <p:cNvSpPr/>
+          <p:nvPr/>
+        </p:nvSpPr>
+        <p:spPr>
+          <a:xfrm>
+            <a:off x="1143000" y="2562523"/>
+            <a:ext cx="9525" cy="3196233"/>
+          </a:xfrm>
+          <a:prstGeom prst="rect">
+            <a:avLst/>
+          </a:prstGeom>
+          <a:solidFill>
+            <a:srgbClr val="D5DBDF"/>
+          </a:solidFill>
+          <a:ln/>
+        </p:spPr>
+      </p:sp>
+      <p:sp>
+        <p:nvSpPr>
+          <p:cNvPr id="9" name="Shape 7"/>
+          <p:cNvSpPr/>
+          <p:nvPr/>
+        </p:nvSpPr>
+        <p:spPr>
+          <a:xfrm>
+            <a:off x="8972550" y="2562523"/>
+            <a:ext cx="9525" cy="3196233"/>
+          </a:xfrm>
+          <a:prstGeom prst="rect">
+            <a:avLst/>
+          </a:prstGeom>
+          <a:solidFill>
+            <a:srgbClr val="D5DBDF"/>
+          </a:solidFill>
+          <a:ln/>
+        </p:spPr>
+      </p:sp>
+      <p:sp>
+        <p:nvSpPr>
+          <p:cNvPr id="10" name="Text 8"/>
+          <p:cNvSpPr/>
+          <p:nvPr/>
+        </p:nvSpPr>
+        <p:spPr>
+          <a:xfrm>
+            <a:off x="1609725" y="3076873"/>
+            <a:ext cx="7596187" cy="447675"/>
+          </a:xfrm>
+          <a:prstGeom prst="rect">
+            <a:avLst/>
+          </a:prstGeom>
+          <a:noFill/>
+          <a:ln/>
+        </p:spPr>
+        <p:txBody>
+          <a:bodyPr wrap="square" lIns="25400" tIns="25400" rIns="25400" bIns="25400" rtlCol="0" anchor="t">
+            <a:normAutofit lnSpcReduction="10000"/>
+          </a:bodyPr>
+          <a:lstStyle/>
+          <a:p>
+            <a:pPr marL="0" indent="0" algn="l">
+              <a:buNone/>
+            </a:pPr>
+            <a:r>
+              <a:rPr lang="en-US" sz="2850" b="1" dirty="0">
+                <a:solidFill>
+                  <a:srgbClr val="14304A"/>
+                </a:solidFill>
+                <a:latin typeface="Arial" pitchFamily="34" charset="0"/>
+                <a:ea typeface="Arial" pitchFamily="34" charset="-122"/>
+                <a:cs typeface="Arial" pitchFamily="34" charset="-120"/>
+              </a:rPr>
+              <a:t>Opportunité</a:t>
+            </a:r>
+            <a:endParaRPr lang="en-US" sz="2850" dirty="0"/>
+          </a:p>
+        </p:txBody>
+      </p:sp>
+      <p:sp>
+        <p:nvSpPr>
+          <p:cNvPr id="11" name="Text 9"/>
+          <p:cNvSpPr/>
+          <p:nvPr/>
+        </p:nvSpPr>
+        <p:spPr>
+          <a:xfrm>
+            <a:off x="1609725" y="3715048"/>
+            <a:ext cx="177701" cy="449461"/>
+          </a:xfrm>
+          <a:prstGeom prst="rect">
+            <a:avLst/>
+          </a:prstGeom>
+          <a:noFill/>
+          <a:ln/>
+        </p:spPr>
+        <p:txBody>
+          <a:bodyPr wrap="square" lIns="25400" tIns="25400" rIns="25400" bIns="25400" rtlCol="0" anchor="t">
+            <a:normAutofit fontScale="92500" lnSpcReduction="10000"/>
+          </a:bodyPr>
+          <a:lstStyle/>
+          <a:p>
+            <a:pPr marL="0" indent="0" algn="l">
+              <a:lnSpc>
+                <a:spcPct val="135000"/>
+              </a:lnSpc>
+              <a:buNone/>
+            </a:pPr>
+            <a:r>
+              <a:rPr lang="en-US" sz="2400" b="1" dirty="0">
+                <a:solidFill>
+                  <a:srgbClr val="14304A"/>
+                </a:solidFill>
+                <a:latin typeface="Arial" pitchFamily="34" charset="0"/>
+                <a:ea typeface="Arial" pitchFamily="34" charset="-122"/>
+                <a:cs typeface="Arial" pitchFamily="34" charset="-120"/>
+              </a:rPr>
+              <a:t>·</a:t>
+            </a:r>
+            <a:endParaRPr lang="en-US" sz="2400" dirty="0"/>
+          </a:p>
+        </p:txBody>
+      </p:sp>
+      <p:sp>
+        <p:nvSpPr>
+          <p:cNvPr id="12" name="Text 10"/>
+          <p:cNvSpPr/>
+          <p:nvPr/>
+        </p:nvSpPr>
+        <p:spPr>
+          <a:xfrm>
+            <a:off x="1863626" y="3715048"/>
+            <a:ext cx="4567863" cy="449461"/>
+          </a:xfrm>
+          <a:prstGeom prst="rect">
+            <a:avLst/>
+          </a:prstGeom>
+          <a:noFill/>
+          <a:ln/>
+        </p:spPr>
+        <p:txBody>
+          <a:bodyPr wrap="square" lIns="25400" tIns="25400" rIns="25400" bIns="25400" rtlCol="0" anchor="t">
+            <a:normAutofit fontScale="92500" lnSpcReduction="10000"/>
+          </a:bodyPr>
+          <a:lstStyle/>
+          <a:p>
+            <a:pPr marL="0" indent="0" algn="l">
+              <a:lnSpc>
+                <a:spcPct val="135000"/>
+              </a:lnSpc>
+              <a:buNone/>
+            </a:pPr>
+            <a:r>
+              <a:rPr lang="en-US" sz="2400" dirty="0">
+                <a:solidFill>
+                  <a:srgbClr val="1E2933"/>
+                </a:solidFill>
+                <a:latin typeface="Arial" pitchFamily="34" charset="0"/>
+                <a:ea typeface="Arial" pitchFamily="34" charset="-122"/>
+                <a:cs typeface="Arial" pitchFamily="34" charset="-120"/>
+              </a:rPr>
+              <a:t>Alléger les tâches répétitives</a:t>
+            </a:r>
+            <a:endParaRPr lang="en-US" sz="2400" dirty="0"/>
+          </a:p>
+        </p:txBody>
+      </p:sp>
+      <p:sp>
+        <p:nvSpPr>
+          <p:cNvPr id="13" name="Text 11"/>
+          <p:cNvSpPr/>
+          <p:nvPr/>
+        </p:nvSpPr>
+        <p:spPr>
+          <a:xfrm>
+            <a:off x="1609725" y="4297859"/>
+            <a:ext cx="177701" cy="449461"/>
+          </a:xfrm>
+          <a:prstGeom prst="rect">
+            <a:avLst/>
+          </a:prstGeom>
+          <a:noFill/>
+          <a:ln/>
+        </p:spPr>
+        <p:txBody>
+          <a:bodyPr wrap="square" lIns="25400" tIns="25400" rIns="25400" bIns="25400" rtlCol="0" anchor="t">
+            <a:normAutofit fontScale="92500" lnSpcReduction="10000"/>
+          </a:bodyPr>
+          <a:lstStyle/>
+          <a:p>
+            <a:pPr marL="0" indent="0" algn="l">
+              <a:lnSpc>
+                <a:spcPct val="135000"/>
+              </a:lnSpc>
+              <a:buNone/>
+            </a:pPr>
+            <a:r>
+              <a:rPr lang="en-US" sz="2400" b="1" dirty="0">
+                <a:solidFill>
+                  <a:srgbClr val="14304A"/>
+                </a:solidFill>
+                <a:latin typeface="Arial" pitchFamily="34" charset="0"/>
+                <a:ea typeface="Arial" pitchFamily="34" charset="-122"/>
+                <a:cs typeface="Arial" pitchFamily="34" charset="-120"/>
+              </a:rPr>
+              <a:t>·</a:t>
+            </a:r>
+            <a:endParaRPr lang="en-US" sz="2400" dirty="0"/>
+          </a:p>
+        </p:txBody>
+      </p:sp>
+      <p:sp>
+        <p:nvSpPr>
+          <p:cNvPr id="14" name="Text 12"/>
+          <p:cNvSpPr/>
+          <p:nvPr/>
+        </p:nvSpPr>
+        <p:spPr>
+          <a:xfrm>
+            <a:off x="1863626" y="4297859"/>
+            <a:ext cx="3099539" cy="449461"/>
+          </a:xfrm>
+          <a:prstGeom prst="rect">
+            <a:avLst/>
+          </a:prstGeom>
+          <a:noFill/>
+          <a:ln/>
+        </p:spPr>
+        <p:txBody>
+          <a:bodyPr wrap="square" lIns="25400" tIns="25400" rIns="25400" bIns="25400" rtlCol="0" anchor="t">
+            <a:normAutofit fontScale="92500" lnSpcReduction="10000"/>
+          </a:bodyPr>
+          <a:lstStyle/>
+          <a:p>
+            <a:pPr marL="0" indent="0" algn="l">
+              <a:lnSpc>
+                <a:spcPct val="135000"/>
+              </a:lnSpc>
+              <a:buNone/>
+            </a:pPr>
+            <a:r>
+              <a:rPr lang="en-US" sz="2400" dirty="0">
+                <a:solidFill>
+                  <a:srgbClr val="1E2933"/>
+                </a:solidFill>
+                <a:latin typeface="Arial" pitchFamily="34" charset="0"/>
+                <a:ea typeface="Arial" pitchFamily="34" charset="-122"/>
+                <a:cs typeface="Arial" pitchFamily="34" charset="-120"/>
+              </a:rPr>
+              <a:t>Accélérer les délais</a:t>
+            </a:r>
+            <a:endParaRPr lang="en-US" sz="2400" dirty="0"/>
+          </a:p>
+        </p:txBody>
+      </p:sp>
+      <p:sp>
+        <p:nvSpPr>
+          <p:cNvPr id="15" name="Text 13"/>
+          <p:cNvSpPr/>
+          <p:nvPr/>
+        </p:nvSpPr>
+        <p:spPr>
+          <a:xfrm>
+            <a:off x="1609725" y="4880670"/>
+            <a:ext cx="177701" cy="449461"/>
+          </a:xfrm>
+          <a:prstGeom prst="rect">
+            <a:avLst/>
+          </a:prstGeom>
+          <a:noFill/>
+          <a:ln/>
+        </p:spPr>
+        <p:txBody>
+          <a:bodyPr wrap="square" lIns="25400" tIns="25400" rIns="25400" bIns="25400" rtlCol="0" anchor="t">
+            <a:normAutofit fontScale="92500" lnSpcReduction="10000"/>
+          </a:bodyPr>
+          <a:lstStyle/>
+          <a:p>
+            <a:pPr marL="0" indent="0" algn="l">
+              <a:lnSpc>
+                <a:spcPct val="135000"/>
+              </a:lnSpc>
+              <a:buNone/>
+            </a:pPr>
+            <a:r>
+              <a:rPr lang="en-US" sz="2400" b="1" dirty="0">
+                <a:solidFill>
+                  <a:srgbClr val="14304A"/>
+                </a:solidFill>
+                <a:latin typeface="Arial" pitchFamily="34" charset="0"/>
+                <a:ea typeface="Arial" pitchFamily="34" charset="-122"/>
+                <a:cs typeface="Arial" pitchFamily="34" charset="-120"/>
+              </a:rPr>
+              <a:t>·</a:t>
+            </a:r>
+            <a:endParaRPr lang="en-US" sz="2400" dirty="0"/>
+          </a:p>
+        </p:txBody>
+      </p:sp>
+      <p:sp>
+        <p:nvSpPr>
+          <p:cNvPr id="16" name="Text 14"/>
+          <p:cNvSpPr/>
+          <p:nvPr/>
+        </p:nvSpPr>
+        <p:spPr>
+          <a:xfrm>
+            <a:off x="1863626" y="4880670"/>
+            <a:ext cx="5360060" cy="449461"/>
+          </a:xfrm>
+          <a:prstGeom prst="rect">
+            <a:avLst/>
+          </a:prstGeom>
+          <a:noFill/>
+          <a:ln/>
+        </p:spPr>
+        <p:txBody>
+          <a:bodyPr wrap="square" lIns="25400" tIns="25400" rIns="25400" bIns="25400" rtlCol="0" anchor="t">
+            <a:normAutofit fontScale="92500" lnSpcReduction="10000"/>
+          </a:bodyPr>
+          <a:lstStyle/>
+          <a:p>
+            <a:pPr marL="0" indent="0" algn="l">
+              <a:lnSpc>
+                <a:spcPct val="135000"/>
+              </a:lnSpc>
+              <a:buNone/>
+            </a:pPr>
+            <a:r>
+              <a:rPr lang="en-US" sz="2400" dirty="0">
+                <a:solidFill>
+                  <a:srgbClr val="1E2933"/>
+                </a:solidFill>
+                <a:latin typeface="Arial" pitchFamily="34" charset="0"/>
+                <a:ea typeface="Arial" pitchFamily="34" charset="-122"/>
+                <a:cs typeface="Arial" pitchFamily="34" charset="-120"/>
+              </a:rPr>
+              <a:t>Fiabiliser ce qui est automatisable</a:t>
+            </a:r>
+            <a:endParaRPr lang="en-US" sz="2400" dirty="0"/>
+          </a:p>
+        </p:txBody>
+      </p:sp>
+      <p:sp>
+        <p:nvSpPr>
+          <p:cNvPr id="17" name="Shape 15"/>
+          <p:cNvSpPr/>
+          <p:nvPr/>
+        </p:nvSpPr>
+        <p:spPr>
+          <a:xfrm>
+            <a:off x="9305925" y="2562523"/>
+            <a:ext cx="7839075" cy="3196233"/>
+          </a:xfrm>
+          <a:prstGeom prst="roundRect">
+            <a:avLst>
+              <a:gd name="adj" fmla="val 4172"/>
+            </a:avLst>
+          </a:prstGeom>
+          <a:solidFill>
+            <a:srgbClr val="FFFFFF"/>
+          </a:solidFill>
+          <a:ln/>
+        </p:spPr>
+      </p:sp>
+      <p:sp>
+        <p:nvSpPr>
+          <p:cNvPr id="18" name="Shape 16"/>
+          <p:cNvSpPr/>
+          <p:nvPr/>
+        </p:nvSpPr>
+        <p:spPr>
+          <a:xfrm>
+            <a:off x="9305925" y="5749230"/>
+            <a:ext cx="7839075" cy="9525"/>
+          </a:xfrm>
+          <a:prstGeom prst="rect">
+            <a:avLst/>
+          </a:prstGeom>
+          <a:solidFill>
+            <a:srgbClr val="D5DBDF"/>
+          </a:solidFill>
+          <a:ln/>
+        </p:spPr>
+      </p:sp>
+      <p:sp>
+        <p:nvSpPr>
+          <p:cNvPr id="19" name="Shape 17"/>
+          <p:cNvSpPr/>
+          <p:nvPr/>
+        </p:nvSpPr>
+        <p:spPr>
+          <a:xfrm>
+            <a:off x="9305925" y="2562523"/>
+            <a:ext cx="7839075" cy="57150"/>
+          </a:xfrm>
+          <a:prstGeom prst="rect">
+            <a:avLst/>
+          </a:prstGeom>
+          <a:solidFill>
+            <a:srgbClr val="C0623F"/>
+          </a:solidFill>
+          <a:ln/>
+        </p:spPr>
+      </p:sp>
+      <p:sp>
+        <p:nvSpPr>
+          <p:cNvPr id="20" name="Shape 18"/>
+          <p:cNvSpPr/>
+          <p:nvPr/>
+        </p:nvSpPr>
+        <p:spPr>
+          <a:xfrm>
+            <a:off x="9305925" y="2562523"/>
+            <a:ext cx="9525" cy="3196233"/>
+          </a:xfrm>
+          <a:prstGeom prst="rect">
+            <a:avLst/>
+          </a:prstGeom>
+          <a:solidFill>
+            <a:srgbClr val="D5DBDF"/>
+          </a:solidFill>
+          <a:ln/>
+        </p:spPr>
+      </p:sp>
+      <p:sp>
+        <p:nvSpPr>
+          <p:cNvPr id="21" name="Shape 19"/>
+          <p:cNvSpPr/>
+          <p:nvPr/>
+        </p:nvSpPr>
+        <p:spPr>
+          <a:xfrm>
+            <a:off x="17135475" y="2562523"/>
+            <a:ext cx="9525" cy="3196233"/>
+          </a:xfrm>
+          <a:prstGeom prst="rect">
+            <a:avLst/>
+          </a:prstGeom>
+          <a:solidFill>
+            <a:srgbClr val="D5DBDF"/>
+          </a:solidFill>
+          <a:ln/>
+        </p:spPr>
+      </p:sp>
+      <p:sp>
+        <p:nvSpPr>
+          <p:cNvPr id="22" name="Text 20"/>
+          <p:cNvSpPr/>
+          <p:nvPr/>
+        </p:nvSpPr>
+        <p:spPr>
+          <a:xfrm>
+            <a:off x="9772650" y="3076873"/>
+            <a:ext cx="7596187" cy="447675"/>
+          </a:xfrm>
+          <a:prstGeom prst="rect">
+            <a:avLst/>
+          </a:prstGeom>
+          <a:noFill/>
+          <a:ln/>
+        </p:spPr>
+        <p:txBody>
+          <a:bodyPr wrap="square" lIns="25400" tIns="25400" rIns="25400" bIns="25400" rtlCol="0" anchor="t">
+            <a:normAutofit lnSpcReduction="10000"/>
+          </a:bodyPr>
+          <a:lstStyle/>
+          <a:p>
+            <a:pPr marL="0" indent="0" algn="l">
+              <a:buNone/>
+            </a:pPr>
+            <a:r>
+              <a:rPr lang="en-US" sz="2850" b="1" dirty="0">
                 <a:solidFill>
                   <a:srgbClr val="C0623F"/>
                 </a:solidFill>
-                <a:latin typeface="Arial"/>
-              </a:rPr>
-              <a:t>SÉQUENCE 0 · POURQUOI</a:t>
-            </a:r>
-          </a:p>
-        </p:txBody>
-      </p:sp>
-      <p:sp>
-        <p:nvSpPr>
-          <p:cNvPr id="4" name="Rectangle 3"/>
-          <p:cNvSpPr/>
-          <p:nvPr/>
-        </p:nvSpPr>
-        <p:spPr>
-          <a:xfrm>
-            <a:off x="1143000" y="3200400"/>
-            <a:ext cx="118872" cy="3749039"/>
-          </a:xfrm>
-          <a:prstGeom prst="rect">
-            <a:avLst/>
-          </a:prstGeom>
-          <a:solidFill>
-            <a:srgbClr val="C0623F"/>
-          </a:solidFill>
-          <a:ln>
-            <a:noFill/>
-          </a:ln>
-        </p:spPr>
-        <p:style>
-          <a:lnRef idx="1">
-            <a:schemeClr val="accent1"/>
-          </a:lnRef>
-          <a:fillRef idx="3">
-            <a:schemeClr val="accent1"/>
-          </a:fillRef>
-          <a:effectRef idx="2">
-            <a:schemeClr val="accent1"/>
-          </a:effectRef>
-          <a:fontRef idx="minor">
-            <a:schemeClr val="lt1"/>
-          </a:fontRef>
-        </p:style>
-        <p:txBody>
-          <a:bodyPr rtlCol="0" anchor="ctr"/>
-          <a:lstStyle/>
-          <a:p>
-            <a:pPr algn="ctr"/>
-          </a:p>
-        </p:txBody>
-      </p:sp>
-      <p:sp>
-        <p:nvSpPr>
-          <p:cNvPr id="5" name="TextBox 4"/>
-          <p:cNvSpPr txBox="1"/>
-          <p:nvPr/>
-        </p:nvSpPr>
-        <p:spPr>
-          <a:xfrm>
-            <a:off x="1554480" y="3108960"/>
-            <a:ext cx="15179040" cy="3931920"/>
-          </a:xfrm>
-          <a:prstGeom prst="rect">
-            <a:avLst/>
-          </a:prstGeom>
-          <a:noFill/>
-        </p:spPr>
-        <p:txBody>
-          <a:bodyPr wrap="square" anchor="ctr">
-            <a:normAutofit/>
-          </a:bodyPr>
-          <a:lstStyle/>
-          <a:p>
-            <a:r>
-              <a:rPr sz="8600" b="1">
-                <a:solidFill>
-                  <a:srgbClr val="FFFFFF"/>
-                </a:solidFill>
-                <a:latin typeface="Arial"/>
-              </a:rPr>
-              <a:t>Un outil à double tranchant.</a:t>
-            </a:r>
-          </a:p>
-        </p:txBody>
-      </p:sp>
-      <p:sp>
-        <p:nvSpPr>
-          <p:cNvPr id="6" name="TextBox 5"/>
-          <p:cNvSpPr txBox="1"/>
-          <p:nvPr/>
-        </p:nvSpPr>
-        <p:spPr>
-          <a:xfrm>
-            <a:off x="16093440" y="9400032"/>
-            <a:ext cx="1143000" cy="310896"/>
-          </a:xfrm>
-          <a:prstGeom prst="rect">
-            <a:avLst/>
-          </a:prstGeom>
-          <a:noFill/>
-        </p:spPr>
-        <p:txBody>
-          <a:bodyPr wrap="none">
-            <a:spAutoFit/>
-          </a:bodyPr>
-          <a:lstStyle/>
-          <a:p>
-            <a:pPr algn="r"/>
-            <a:r>
-              <a:rPr sz="1100">
-                <a:solidFill>
-                  <a:srgbClr val="F7F2EA"/>
-                </a:solidFill>
-                <a:latin typeface="Arial"/>
+                <a:latin typeface="Arial" pitchFamily="34" charset="0"/>
+                <a:ea typeface="Arial" pitchFamily="34" charset="-122"/>
+                <a:cs typeface="Arial" pitchFamily="34" charset="-120"/>
+              </a:rPr>
+              <a:t>Risque</a:t>
+            </a:r>
+            <a:endParaRPr lang="en-US" sz="2850" dirty="0"/>
+          </a:p>
+        </p:txBody>
+      </p:sp>
+      <p:sp>
+        <p:nvSpPr>
+          <p:cNvPr id="23" name="Text 21"/>
+          <p:cNvSpPr/>
+          <p:nvPr/>
+        </p:nvSpPr>
+        <p:spPr>
+          <a:xfrm>
+            <a:off x="9772650" y="3715048"/>
+            <a:ext cx="177701" cy="449461"/>
+          </a:xfrm>
+          <a:prstGeom prst="rect">
+            <a:avLst/>
+          </a:prstGeom>
+          <a:noFill/>
+          <a:ln/>
+        </p:spPr>
+        <p:txBody>
+          <a:bodyPr wrap="square" lIns="25400" tIns="25400" rIns="25400" bIns="25400" rtlCol="0" anchor="t">
+            <a:normAutofit fontScale="92500" lnSpcReduction="10000"/>
+          </a:bodyPr>
+          <a:lstStyle/>
+          <a:p>
+            <a:pPr marL="0" indent="0" algn="l">
+              <a:lnSpc>
+                <a:spcPct val="135000"/>
+              </a:lnSpc>
+              <a:buNone/>
+            </a:pPr>
+            <a:r>
+              <a:rPr lang="en-US" sz="2400" b="1" dirty="0">
+                <a:solidFill>
+                  <a:srgbClr val="C0623F"/>
+                </a:solidFill>
+                <a:latin typeface="Arial" pitchFamily="34" charset="0"/>
+                <a:ea typeface="Arial" pitchFamily="34" charset="-122"/>
+                <a:cs typeface="Arial" pitchFamily="34" charset="-120"/>
+              </a:rPr>
+              <a:t>·</a:t>
+            </a:r>
+            <a:endParaRPr lang="en-US" sz="2400" dirty="0"/>
+          </a:p>
+        </p:txBody>
+      </p:sp>
+      <p:sp>
+        <p:nvSpPr>
+          <p:cNvPr id="24" name="Text 22"/>
+          <p:cNvSpPr/>
+          <p:nvPr/>
+        </p:nvSpPr>
+        <p:spPr>
+          <a:xfrm>
+            <a:off x="10026551" y="3715048"/>
+            <a:ext cx="5594821" cy="449461"/>
+          </a:xfrm>
+          <a:prstGeom prst="rect">
+            <a:avLst/>
+          </a:prstGeom>
+          <a:noFill/>
+          <a:ln/>
+        </p:spPr>
+        <p:txBody>
+          <a:bodyPr wrap="square" lIns="25400" tIns="25400" rIns="25400" bIns="25400" rtlCol="0" anchor="t">
+            <a:normAutofit fontScale="92500" lnSpcReduction="10000"/>
+          </a:bodyPr>
+          <a:lstStyle/>
+          <a:p>
+            <a:pPr marL="0" indent="0" algn="l">
+              <a:lnSpc>
+                <a:spcPct val="135000"/>
+              </a:lnSpc>
+              <a:buNone/>
+            </a:pPr>
+            <a:r>
+              <a:rPr lang="en-US" sz="2400" dirty="0">
+                <a:solidFill>
+                  <a:srgbClr val="1E2933"/>
+                </a:solidFill>
+                <a:latin typeface="Arial" pitchFamily="34" charset="0"/>
+                <a:ea typeface="Arial" pitchFamily="34" charset="-122"/>
+                <a:cs typeface="Arial" pitchFamily="34" charset="-120"/>
+              </a:rPr>
+              <a:t>Usage sauvage de données patient</a:t>
+            </a:r>
+            <a:endParaRPr lang="en-US" sz="2400" dirty="0"/>
+          </a:p>
+        </p:txBody>
+      </p:sp>
+      <p:sp>
+        <p:nvSpPr>
+          <p:cNvPr id="25" name="Text 23"/>
+          <p:cNvSpPr/>
+          <p:nvPr/>
+        </p:nvSpPr>
+        <p:spPr>
+          <a:xfrm>
+            <a:off x="9772650" y="4297859"/>
+            <a:ext cx="177701" cy="449461"/>
+          </a:xfrm>
+          <a:prstGeom prst="rect">
+            <a:avLst/>
+          </a:prstGeom>
+          <a:noFill/>
+          <a:ln/>
+        </p:spPr>
+        <p:txBody>
+          <a:bodyPr wrap="square" lIns="25400" tIns="25400" rIns="25400" bIns="25400" rtlCol="0" anchor="t">
+            <a:normAutofit fontScale="92500" lnSpcReduction="10000"/>
+          </a:bodyPr>
+          <a:lstStyle/>
+          <a:p>
+            <a:pPr marL="0" indent="0" algn="l">
+              <a:lnSpc>
+                <a:spcPct val="135000"/>
+              </a:lnSpc>
+              <a:buNone/>
+            </a:pPr>
+            <a:r>
+              <a:rPr lang="en-US" sz="2400" b="1" dirty="0">
+                <a:solidFill>
+                  <a:srgbClr val="C0623F"/>
+                </a:solidFill>
+                <a:latin typeface="Arial" pitchFamily="34" charset="0"/>
+                <a:ea typeface="Arial" pitchFamily="34" charset="-122"/>
+                <a:cs typeface="Arial" pitchFamily="34" charset="-120"/>
+              </a:rPr>
+              <a:t>·</a:t>
+            </a:r>
+            <a:endParaRPr lang="en-US" sz="2400" dirty="0"/>
+          </a:p>
+        </p:txBody>
+      </p:sp>
+      <p:sp>
+        <p:nvSpPr>
+          <p:cNvPr id="26" name="Text 24"/>
+          <p:cNvSpPr/>
+          <p:nvPr/>
+        </p:nvSpPr>
+        <p:spPr>
+          <a:xfrm>
+            <a:off x="10026551" y="4297859"/>
+            <a:ext cx="4907563" cy="449461"/>
+          </a:xfrm>
+          <a:prstGeom prst="rect">
+            <a:avLst/>
+          </a:prstGeom>
+          <a:noFill/>
+          <a:ln/>
+        </p:spPr>
+        <p:txBody>
+          <a:bodyPr wrap="square" lIns="25400" tIns="25400" rIns="25400" bIns="25400" rtlCol="0" anchor="t">
+            <a:normAutofit fontScale="92500" lnSpcReduction="10000"/>
+          </a:bodyPr>
+          <a:lstStyle/>
+          <a:p>
+            <a:pPr marL="0" indent="0" algn="l">
+              <a:lnSpc>
+                <a:spcPct val="135000"/>
+              </a:lnSpc>
+              <a:buNone/>
+            </a:pPr>
+            <a:r>
+              <a:rPr lang="en-US" sz="2400" dirty="0">
+                <a:solidFill>
+                  <a:srgbClr val="1E2933"/>
+                </a:solidFill>
+                <a:latin typeface="Arial" pitchFamily="34" charset="0"/>
+                <a:ea typeface="Arial" pitchFamily="34" charset="-122"/>
+                <a:cs typeface="Arial" pitchFamily="34" charset="-120"/>
+              </a:rPr>
+              <a:t>Prendre du retard si on l'ignore</a:t>
+            </a:r>
+            <a:endParaRPr lang="en-US" sz="2400" dirty="0"/>
+          </a:p>
+        </p:txBody>
+      </p:sp>
+      <p:sp>
+        <p:nvSpPr>
+          <p:cNvPr id="27" name="Text 25"/>
+          <p:cNvSpPr/>
+          <p:nvPr/>
+        </p:nvSpPr>
+        <p:spPr>
+          <a:xfrm>
+            <a:off x="1143000" y="6177855"/>
+            <a:ext cx="17602200" cy="409575"/>
+          </a:xfrm>
+          <a:prstGeom prst="rect">
+            <a:avLst/>
+          </a:prstGeom>
+          <a:noFill/>
+          <a:ln/>
+        </p:spPr>
+        <p:txBody>
+          <a:bodyPr wrap="square" lIns="25400" tIns="25400" rIns="25400" bIns="25400" rtlCol="0" anchor="t">
+            <a:normAutofit lnSpcReduction="10000"/>
+          </a:bodyPr>
+          <a:lstStyle/>
+          <a:p>
+            <a:pPr marL="0" indent="0" algn="l">
+              <a:buNone/>
+            </a:pPr>
+            <a:r>
+              <a:rPr lang="en-US" sz="2400" dirty="0">
+                <a:solidFill>
+                  <a:srgbClr val="5B6B79"/>
+                </a:solidFill>
+                <a:latin typeface="Arial" pitchFamily="34" charset="0"/>
+                <a:ea typeface="Arial" pitchFamily="34" charset="-122"/>
+                <a:cs typeface="Arial" pitchFamily="34" charset="-120"/>
+              </a:rPr>
+              <a:t>C'est pour ça qu'on est là aujourd'hui.</a:t>
+            </a:r>
+            <a:endParaRPr lang="en-US" sz="2400" dirty="0"/>
+          </a:p>
+        </p:txBody>
+      </p:sp>
+      <p:sp>
+        <p:nvSpPr>
+          <p:cNvPr id="28" name="Shape 26"/>
+          <p:cNvSpPr/>
+          <p:nvPr/>
+        </p:nvSpPr>
+        <p:spPr>
+          <a:xfrm>
+            <a:off x="1143000" y="9020175"/>
+            <a:ext cx="16002000" cy="9525"/>
+          </a:xfrm>
+          <a:prstGeom prst="rect">
+            <a:avLst/>
+          </a:prstGeom>
+          <a:solidFill>
+            <a:srgbClr val="D5DBDF"/>
+          </a:solidFill>
+          <a:ln/>
+        </p:spPr>
+      </p:sp>
+      <p:pic>
+        <p:nvPicPr>
+          <p:cNvPr id="29" name="Image 0" descr="preencoded.png"/>
+          <p:cNvPicPr>
+            <a:picLocks noChangeAspect="1"/>
+          </p:cNvPicPr>
+          <p:nvPr/>
+        </p:nvPicPr>
+        <p:blipFill>
+          <a:blip r:embed="rId3"/>
+          <a:stretch>
+            <a:fillRect/>
+          </a:stretch>
+        </p:blipFill>
+        <p:spPr>
+          <a:xfrm>
+            <a:off x="1143000" y="9239250"/>
+            <a:ext cx="393204" cy="590550"/>
+          </a:xfrm>
+          <a:prstGeom prst="rect">
+            <a:avLst/>
+          </a:prstGeom>
+        </p:spPr>
+      </p:pic>
+      <p:sp>
+        <p:nvSpPr>
+          <p:cNvPr id="30" name="Text 27"/>
+          <p:cNvSpPr/>
+          <p:nvPr/>
+        </p:nvSpPr>
+        <p:spPr>
+          <a:xfrm>
+            <a:off x="16228070" y="9396413"/>
+            <a:ext cx="993130" cy="314325"/>
+          </a:xfrm>
+          <a:prstGeom prst="rect">
+            <a:avLst/>
+          </a:prstGeom>
+          <a:noFill/>
+          <a:ln/>
+        </p:spPr>
+        <p:txBody>
+          <a:bodyPr wrap="square" lIns="25400" tIns="25400" rIns="25400" bIns="25400" rtlCol="0" anchor="t">
+            <a:normAutofit lnSpcReduction="10000"/>
+          </a:bodyPr>
+          <a:lstStyle/>
+          <a:p>
+            <a:pPr marL="0" indent="0" algn="l">
+              <a:buNone/>
+            </a:pPr>
+            <a:r>
+              <a:rPr lang="en-US" sz="1800" kern="0" spc="150" dirty="0">
+                <a:solidFill>
+                  <a:srgbClr val="8A9097"/>
+                </a:solidFill>
+                <a:latin typeface="Arial" pitchFamily="34" charset="0"/>
+                <a:ea typeface="Arial" pitchFamily="34" charset="-122"/>
+                <a:cs typeface="Arial" pitchFamily="34" charset="-120"/>
               </a:rPr>
               <a:t>04 / 23</a:t>
             </a:r>
+            <a:endParaRPr lang="en-US" sz="1800" dirty="0"/>
           </a:p>
         </p:txBody>
       </p:sp>
@@ -16828,7 +17596,7 @@
         <p:spPr>
           <a:xfrm>
             <a:off x="1143000" y="2933998"/>
-            <a:ext cx="5162550" cy="3356372"/>
+            <a:ext cx="7589520" cy="3356372"/>
           </a:xfrm>
           <a:prstGeom prst="roundRect">
             <a:avLst>
@@ -16850,7 +17618,7 @@
         <p:spPr>
           <a:xfrm>
             <a:off x="1143000" y="6280845"/>
-            <a:ext cx="5162550" cy="9525"/>
+            <a:ext cx="7589520" cy="9525"/>
           </a:xfrm>
           <a:prstGeom prst="rect">
             <a:avLst/>
@@ -16870,7 +17638,7 @@
         <p:spPr>
           <a:xfrm>
             <a:off x="1143000" y="2933998"/>
-            <a:ext cx="5162550" cy="47625"/>
+            <a:ext cx="7589520" cy="47625"/>
           </a:xfrm>
           <a:prstGeom prst="rect">
             <a:avLst/>
@@ -16909,7 +17677,7 @@
         </p:nvSpPr>
         <p:spPr>
           <a:xfrm>
-            <a:off x="6296025" y="2933998"/>
+            <a:off x="8732520" y="2933998"/>
             <a:ext cx="9525" cy="3356372"/>
           </a:xfrm>
           <a:prstGeom prst="rect">
@@ -16991,7 +17759,7 @@
         <p:spPr>
           <a:xfrm>
             <a:off x="1533525" y="3896023"/>
-            <a:ext cx="4381500" cy="1101030"/>
+            <a:ext cx="6766560" cy="1101030"/>
           </a:xfrm>
           <a:prstGeom prst="roundRect">
             <a:avLst>
@@ -17013,7 +17781,7 @@
         <p:spPr>
           <a:xfrm>
             <a:off x="1762125" y="4086523"/>
-            <a:ext cx="4055745" cy="758130"/>
+            <a:ext cx="6400800" cy="758130"/>
           </a:xfrm>
           <a:prstGeom prst="rect">
             <a:avLst/>
@@ -17057,7 +17825,7 @@
         <p:spPr>
           <a:xfrm>
             <a:off x="1533525" y="5206603"/>
-            <a:ext cx="4512945" cy="731341"/>
+            <a:ext cx="6766560" cy="731341"/>
           </a:xfrm>
           <a:prstGeom prst="rect">
             <a:avLst/>
@@ -17100,8 +17868,8 @@
         </p:nvSpPr>
         <p:spPr>
           <a:xfrm>
-            <a:off x="6572250" y="2933998"/>
-            <a:ext cx="5162550" cy="3356372"/>
+            <a:off x="9553193" y="2933998"/>
+            <a:ext cx="7589520" cy="3356372"/>
           </a:xfrm>
           <a:prstGeom prst="roundRect">
             <a:avLst>
@@ -17122,8 +17890,8 @@
         </p:nvSpPr>
         <p:spPr>
           <a:xfrm>
-            <a:off x="6572250" y="6280845"/>
-            <a:ext cx="5162550" cy="9525"/>
+            <a:off x="9553193" y="6280845"/>
+            <a:ext cx="7589520" cy="9525"/>
           </a:xfrm>
           <a:prstGeom prst="rect">
             <a:avLst/>
@@ -17142,8 +17910,8 @@
         </p:nvSpPr>
         <p:spPr>
           <a:xfrm>
-            <a:off x="6572250" y="2933998"/>
-            <a:ext cx="5162550" cy="47625"/>
+            <a:off x="9553193" y="2933998"/>
+            <a:ext cx="7589520" cy="47625"/>
           </a:xfrm>
           <a:prstGeom prst="rect">
             <a:avLst/>
@@ -17162,7 +17930,7 @@
         </p:nvSpPr>
         <p:spPr>
           <a:xfrm>
-            <a:off x="6572250" y="2933998"/>
+            <a:off x="9553193" y="2933998"/>
             <a:ext cx="9525" cy="3356372"/>
           </a:xfrm>
           <a:prstGeom prst="rect">
@@ -17182,7 +17950,7 @@
         </p:nvSpPr>
         <p:spPr>
           <a:xfrm>
-            <a:off x="11725275" y="2933998"/>
+            <a:off x="17145000" y="2933998"/>
             <a:ext cx="9525" cy="3356372"/>
           </a:xfrm>
           <a:prstGeom prst="rect">
@@ -17202,7 +17970,7 @@
         </p:nvSpPr>
         <p:spPr>
           <a:xfrm>
-            <a:off x="6962775" y="3438823"/>
+            <a:off x="9943718" y="3438823"/>
             <a:ext cx="171450" cy="171450"/>
           </a:xfrm>
           <a:prstGeom prst="ellipse">
@@ -17222,7 +17990,7 @@
         </p:nvSpPr>
         <p:spPr>
           <a:xfrm>
-            <a:off x="7267575" y="3362623"/>
+            <a:off x="10248518" y="3362623"/>
             <a:ext cx="1968788" cy="361950"/>
           </a:xfrm>
           <a:prstGeom prst="rect">
@@ -17263,7 +18031,7 @@
         </p:nvSpPr>
         <p:spPr>
           <a:xfrm>
-            <a:off x="6962775" y="3896023"/>
+            <a:off x="9943718" y="3896023"/>
             <a:ext cx="2276773" cy="400050"/>
           </a:xfrm>
           <a:prstGeom prst="roundRect">
@@ -17285,7 +18053,7 @@
         </p:nvSpPr>
         <p:spPr>
           <a:xfrm>
-            <a:off x="7134225" y="3972223"/>
+            <a:off x="10115168" y="3972223"/>
             <a:ext cx="2010073" cy="285750"/>
           </a:xfrm>
           <a:prstGeom prst="rect">
@@ -17326,7 +18094,7 @@
         </p:nvSpPr>
         <p:spPr>
           <a:xfrm>
-            <a:off x="9334798" y="3896023"/>
+            <a:off x="12315741" y="3896023"/>
             <a:ext cx="1775817" cy="400050"/>
           </a:xfrm>
           <a:prstGeom prst="roundRect">
@@ -17348,7 +18116,7 @@
         </p:nvSpPr>
         <p:spPr>
           <a:xfrm>
-            <a:off x="9506248" y="3972223"/>
+            <a:off x="12487191" y="3972223"/>
             <a:ext cx="1509117" cy="285750"/>
           </a:xfrm>
           <a:prstGeom prst="rect">
@@ -17389,7 +18157,7 @@
         </p:nvSpPr>
         <p:spPr>
           <a:xfrm>
-            <a:off x="6962775" y="4391323"/>
+            <a:off x="9943718" y="4391323"/>
             <a:ext cx="1554361" cy="400050"/>
           </a:xfrm>
           <a:prstGeom prst="roundRect">
@@ -17411,7 +18179,7 @@
         </p:nvSpPr>
         <p:spPr>
           <a:xfrm>
-            <a:off x="7134225" y="4467523"/>
+            <a:off x="10115168" y="4467523"/>
             <a:ext cx="1287661" cy="285750"/>
           </a:xfrm>
           <a:prstGeom prst="rect">
@@ -17452,8 +18220,8 @@
         </p:nvSpPr>
         <p:spPr>
           <a:xfrm>
-            <a:off x="6962775" y="5000923"/>
-            <a:ext cx="4512945" cy="731341"/>
+            <a:off x="9943718" y="5000923"/>
+            <a:ext cx="6766560" cy="731341"/>
           </a:xfrm>
           <a:prstGeom prst="rect">
             <a:avLst/>
@@ -17483,113 +18251,6 @@
                 <a:cs typeface="Arial" pitchFamily="34" charset="-120"/>
               </a:rPr>
               <a:t>Réponse pertinente, directement exploitable.</a:t>
-            </a:r>
-            <a:endParaRPr lang="en-US" sz="1950" dirty="0"/>
-          </a:p>
-        </p:txBody>
-      </p:sp>
-      <p:sp>
-        <p:nvSpPr>
-          <p:cNvPr id="30" name="Shape 28"/>
-          <p:cNvSpPr/>
-          <p:nvPr/>
-        </p:nvSpPr>
-        <p:spPr>
-          <a:xfrm>
-            <a:off x="12001500" y="2933998"/>
-            <a:ext cx="5143500" cy="3356372"/>
-          </a:xfrm>
-          <a:prstGeom prst="roundRect">
-            <a:avLst>
-              <a:gd name="adj" fmla="val 3973"/>
-            </a:avLst>
-          </a:prstGeom>
-          <a:solidFill>
-            <a:srgbClr val="14304A"/>
-          </a:solidFill>
-          <a:ln/>
-        </p:spPr>
-      </p:sp>
-      <p:sp>
-        <p:nvSpPr>
-          <p:cNvPr id="31" name="Text 29"/>
-          <p:cNvSpPr/>
-          <p:nvPr/>
-        </p:nvSpPr>
-        <p:spPr>
-          <a:xfrm>
-            <a:off x="12382500" y="3998863"/>
-            <a:ext cx="4819650" cy="361950"/>
-          </a:xfrm>
-          <a:prstGeom prst="rect">
-            <a:avLst/>
-          </a:prstGeom>
-          <a:noFill/>
-          <a:ln/>
-        </p:spPr>
-        <p:txBody>
-          <a:bodyPr wrap="square" lIns="25400" tIns="25400" rIns="25400" bIns="25400" rtlCol="0" anchor="t">
-            <a:normAutofit lnSpcReduction="10000"/>
-          </a:bodyPr>
-          <a:lstStyle/>
-          <a:p>
-            <a:pPr marL="0" indent="0" algn="l">
-              <a:buNone/>
-            </a:pPr>
-            <a:r>
-              <a:rPr lang="en-US" sz="2250" b="1" dirty="0">
-                <a:solidFill>
-                  <a:srgbClr val="FFFFFF"/>
-                </a:solidFill>
-                <a:latin typeface="Arial" pitchFamily="34" charset="0"/>
-                <a:ea typeface="Arial" pitchFamily="34" charset="-122"/>
-                <a:cs typeface="Arial" pitchFamily="34" charset="-120"/>
-              </a:rPr>
-              <a:t>Un outil généraliste</a:t>
-            </a:r>
-            <a:endParaRPr lang="en-US" sz="2250" dirty="0"/>
-          </a:p>
-        </p:txBody>
-      </p:sp>
-      <p:sp>
-        <p:nvSpPr>
-          <p:cNvPr id="32" name="Text 30"/>
-          <p:cNvSpPr/>
-          <p:nvPr/>
-        </p:nvSpPr>
-        <p:spPr>
-          <a:xfrm>
-            <a:off x="12382500" y="4532263"/>
-            <a:ext cx="4512945" cy="731341"/>
-          </a:xfrm>
-          <a:prstGeom prst="rect">
-            <a:avLst/>
-          </a:prstGeom>
-          <a:noFill/>
-          <a:ln/>
-        </p:spPr>
-        <p:txBody>
-          <a:bodyPr wrap="square" lIns="25400" tIns="25400" rIns="25400" bIns="25400" rtlCol="0" anchor="t">
-            <a:normAutofit fontScale="92500" lnSpcReduction="20000"/>
-          </a:bodyPr>
-          <a:lstStyle/>
-          <a:p>
-            <a:pPr marL="0" indent="0" algn="l">
-              <a:lnSpc>
-                <a:spcPct val="140000"/>
-              </a:lnSpc>
-              <a:buNone/>
-            </a:pPr>
-            <a:r>
-              <a:rPr lang="en-US" sz="1950" dirty="0">
-                <a:solidFill>
-                  <a:srgbClr val="C7D2DB"/>
-                </a:solidFill>
-                <a:latin typeface="Arial" pitchFamily="34" charset="0"/>
-                <a:ea typeface="Arial" pitchFamily="34" charset="-122"/>
-                <a:cs typeface="Arial" pitchFamily="34" charset="-120"/>
-              </a:rPr>
-              <a:t>Le contexte le transforme en aide réellement utile.</a:t>
             </a:r>
             <a:endParaRPr lang="en-US" sz="1950" dirty="0"/>
           </a:p>
@@ -18748,7 +19409,7 @@
     <p:bg>
       <p:bgPr>
         <a:solidFill>
-          <a:srgbClr val="14304A"/>
+          <a:srgbClr val="F7F2EA"/>
         </a:solidFill>
         <a:effectLst/>
       </p:bgPr>
@@ -18769,14 +19430,14 @@
       </p:grpSpPr>
       <p:sp>
         <p:nvSpPr>
-          <p:cNvPr id="2" name="Rectangle 1"/>
-          <p:cNvSpPr/>
-          <p:nvPr/>
-        </p:nvSpPr>
-        <p:spPr>
-          <a:xfrm>
-            <a:off x="1143000" y="1042415"/>
-            <a:ext cx="457200" cy="36576"/>
+          <p:cNvPr id="2" name="Shape 0"/>
+          <p:cNvSpPr/>
+          <p:nvPr/>
+        </p:nvSpPr>
+        <p:spPr>
+          <a:xfrm>
+            <a:off x="1143000" y="2139404"/>
+            <a:ext cx="381000" cy="19050"/>
           </a:xfrm>
           <a:prstGeom prst="rect">
             <a:avLst/>
@@ -18784,76 +19445,214 @@
           <a:solidFill>
             <a:srgbClr val="C0623F"/>
           </a:solidFill>
-          <a:ln>
-            <a:noFill/>
-          </a:ln>
-        </p:spPr>
-        <p:style>
-          <a:lnRef idx="1">
-            <a:schemeClr val="accent1"/>
-          </a:lnRef>
-          <a:fillRef idx="3">
-            <a:schemeClr val="accent1"/>
-          </a:fillRef>
-          <a:effectRef idx="2">
-            <a:schemeClr val="accent1"/>
-          </a:effectRef>
-          <a:fontRef idx="minor">
-            <a:schemeClr val="lt1"/>
-          </a:fontRef>
-        </p:style>
-        <p:txBody>
-          <a:bodyPr rtlCol="0" anchor="ctr"/>
-          <a:lstStyle/>
-          <a:p>
-            <a:pPr algn="ctr"/>
-          </a:p>
-        </p:txBody>
-      </p:sp>
-      <p:sp>
-        <p:nvSpPr>
-          <p:cNvPr id="3" name="TextBox 2"/>
-          <p:cNvSpPr txBox="1"/>
-          <p:nvPr/>
-        </p:nvSpPr>
-        <p:spPr>
-          <a:xfrm>
-            <a:off x="1737360" y="868680"/>
-            <a:ext cx="9144000" cy="365760"/>
-          </a:xfrm>
-          <a:prstGeom prst="rect">
-            <a:avLst/>
-          </a:prstGeom>
-          <a:noFill/>
-        </p:spPr>
-        <p:txBody>
-          <a:bodyPr wrap="none">
-            <a:spAutoFit/>
-          </a:bodyPr>
-          <a:lstStyle/>
-          <a:p>
-            <a:r>
-              <a:rPr sz="1600" b="1">
+          <a:ln/>
+        </p:spPr>
+      </p:sp>
+      <p:sp>
+        <p:nvSpPr>
+          <p:cNvPr id="3" name="Text 1"/>
+          <p:cNvSpPr/>
+          <p:nvPr/>
+        </p:nvSpPr>
+        <p:spPr>
+          <a:xfrm>
+            <a:off x="1676400" y="2015579"/>
+            <a:ext cx="3670563" cy="304800"/>
+          </a:xfrm>
+          <a:prstGeom prst="rect">
+            <a:avLst/>
+          </a:prstGeom>
+          <a:noFill/>
+          <a:ln/>
+        </p:spPr>
+        <p:txBody>
+          <a:bodyPr wrap="square" lIns="25400" tIns="25400" rIns="25400" bIns="25400" rtlCol="0" anchor="t">
+            <a:normAutofit lnSpcReduction="10000"/>
+          </a:bodyPr>
+          <a:lstStyle/>
+          <a:p>
+            <a:pPr marL="0" indent="0" algn="l">
+              <a:buNone/>
+            </a:pPr>
+            <a:r>
+              <a:rPr lang="en-US" sz="1800" b="1" kern="0" spc="300" dirty="0">
                 <a:solidFill>
                   <a:srgbClr val="C0623F"/>
                 </a:solidFill>
-                <a:latin typeface="Arial"/>
+                <a:latin typeface="Arial" pitchFamily="34" charset="0"/>
+                <a:ea typeface="Arial" pitchFamily="34" charset="-122"/>
+                <a:cs typeface="Arial" pitchFamily="34" charset="-120"/>
               </a:rPr>
               <a:t>HISTOIRE VRAIE · 2023</a:t>
             </a:r>
-          </a:p>
-        </p:txBody>
-      </p:sp>
-      <p:sp>
-        <p:nvSpPr>
-          <p:cNvPr id="4" name="Rectangle 3"/>
-          <p:cNvSpPr/>
-          <p:nvPr/>
-        </p:nvSpPr>
-        <p:spPr>
-          <a:xfrm>
-            <a:off x="1143000" y="3200400"/>
-            <a:ext cx="118872" cy="3749039"/>
+            <a:endParaRPr lang="en-US" sz="1800" dirty="0"/>
+          </a:p>
+        </p:txBody>
+      </p:sp>
+      <p:sp>
+        <p:nvSpPr>
+          <p:cNvPr id="4" name="Text 2"/>
+          <p:cNvSpPr/>
+          <p:nvPr/>
+        </p:nvSpPr>
+        <p:spPr>
+          <a:xfrm>
+            <a:off x="1143000" y="2568029"/>
+            <a:ext cx="17602200" cy="895350"/>
+          </a:xfrm>
+          <a:prstGeom prst="rect">
+            <a:avLst/>
+          </a:prstGeom>
+          <a:noFill/>
+          <a:ln/>
+        </p:spPr>
+        <p:txBody>
+          <a:bodyPr wrap="square" lIns="25400" tIns="25400" rIns="25400" bIns="25400" rtlCol="0" anchor="t">
+            <a:normAutofit fontScale="92500" lnSpcReduction="20000"/>
+          </a:bodyPr>
+          <a:lstStyle/>
+          <a:p>
+            <a:pPr marL="0" indent="0" algn="l">
+              <a:lnSpc>
+                <a:spcPct val="60000"/>
+              </a:lnSpc>
+              <a:buNone/>
+            </a:pPr>
+            <a:r>
+              <a:rPr lang="en-US" sz="11250" b="1" dirty="0">
+                <a:solidFill>
+                  <a:srgbClr val="C0623F"/>
+                </a:solidFill>
+                <a:latin typeface="Arial" pitchFamily="34" charset="0"/>
+                <a:ea typeface="Arial" pitchFamily="34" charset="-122"/>
+                <a:cs typeface="Arial" pitchFamily="34" charset="-120"/>
+              </a:rPr>
+              <a:t>“</a:t>
+            </a:r>
+            <a:endParaRPr lang="en-US" sz="11250" dirty="0"/>
+          </a:p>
+        </p:txBody>
+      </p:sp>
+      <p:sp>
+        <p:nvSpPr>
+          <p:cNvPr id="5" name="Text 3"/>
+          <p:cNvSpPr/>
+          <p:nvPr/>
+        </p:nvSpPr>
+        <p:spPr>
+          <a:xfrm>
+            <a:off x="1143000" y="3711029"/>
+            <a:ext cx="15304770" cy="1560314"/>
+          </a:xfrm>
+          <a:prstGeom prst="rect">
+            <a:avLst/>
+          </a:prstGeom>
+          <a:noFill/>
+          <a:ln/>
+        </p:spPr>
+        <p:txBody>
+          <a:bodyPr wrap="square" lIns="25400" tIns="25400" rIns="25400" bIns="25400" rtlCol="0" anchor="t">
+            <a:normAutofit fontScale="92500" lnSpcReduction="20000"/>
+          </a:bodyPr>
+          <a:lstStyle/>
+          <a:p>
+            <a:pPr marL="0" indent="0" algn="l">
+              <a:lnSpc>
+                <a:spcPct val="108000"/>
+              </a:lnSpc>
+              <a:buNone/>
+            </a:pPr>
+            <a:r>
+              <a:rPr lang="en-US" sz="5550" b="1" kern="0" spc="-112" dirty="0">
+                <a:solidFill>
+                  <a:srgbClr val="14304A"/>
+                </a:solidFill>
+                <a:latin typeface="Arial" pitchFamily="34" charset="0"/>
+                <a:ea typeface="Arial" pitchFamily="34" charset="-122"/>
+                <a:cs typeface="Arial" pitchFamily="34" charset="-120"/>
+              </a:rPr>
+              <a:t>Un avocat a cité six jugements à l'appui de son dossier. Aucun n'existait.</a:t>
+            </a:r>
+            <a:endParaRPr lang="en-US" sz="5550" dirty="0"/>
+          </a:p>
+        </p:txBody>
+      </p:sp>
+      <p:sp>
+        <p:nvSpPr>
+          <p:cNvPr id="6" name="Text 4"/>
+          <p:cNvSpPr/>
+          <p:nvPr/>
+        </p:nvSpPr>
+        <p:spPr>
+          <a:xfrm>
+            <a:off x="1143000" y="5518993"/>
+            <a:ext cx="14519910" cy="998041"/>
+          </a:xfrm>
+          <a:prstGeom prst="rect">
+            <a:avLst/>
+          </a:prstGeom>
+          <a:noFill/>
+          <a:ln/>
+        </p:spPr>
+        <p:txBody>
+          <a:bodyPr wrap="square" lIns="25400" tIns="25400" rIns="25400" bIns="25400" rtlCol="0" anchor="t">
+            <a:normAutofit fontScale="92500" lnSpcReduction="20000"/>
+          </a:bodyPr>
+          <a:lstStyle/>
+          <a:p>
+            <a:pPr marL="0" indent="0" algn="l">
+              <a:lnSpc>
+                <a:spcPct val="140000"/>
+              </a:lnSpc>
+              <a:buNone/>
+            </a:pPr>
+            <a:r>
+              <a:rPr lang="en-US" sz="2700" dirty="0">
+                <a:solidFill>
+                  <a:srgbClr val="1E2933"/>
+                </a:solidFill>
+                <a:latin typeface="Arial" pitchFamily="34" charset="0"/>
+                <a:ea typeface="Arial" pitchFamily="34" charset="-122"/>
+                <a:cs typeface="Arial" pitchFamily="34" charset="-120"/>
+              </a:rPr>
+              <a:t>Il les avait demandés à une IA et, confiant, ne les a pas vérifiés. Le juge, lui, a cherché. Il n'a rien trouvé.</a:t>
+            </a:r>
+            <a:endParaRPr lang="en-US" sz="2700" dirty="0"/>
+          </a:p>
+        </p:txBody>
+      </p:sp>
+      <p:sp>
+        <p:nvSpPr>
+          <p:cNvPr id="7" name="Shape 5"/>
+          <p:cNvSpPr/>
+          <p:nvPr/>
+        </p:nvSpPr>
+        <p:spPr>
+          <a:xfrm>
+            <a:off x="1143000" y="6840885"/>
+            <a:ext cx="13535025" cy="992386"/>
+          </a:xfrm>
+          <a:prstGeom prst="roundRect">
+            <a:avLst>
+              <a:gd name="adj" fmla="val 9598"/>
+            </a:avLst>
+          </a:prstGeom>
+          <a:solidFill>
+            <a:srgbClr val="FBEDE7"/>
+          </a:solidFill>
+          <a:ln/>
+        </p:spPr>
+      </p:sp>
+      <p:sp>
+        <p:nvSpPr>
+          <p:cNvPr id="8" name="Shape 6"/>
+          <p:cNvSpPr/>
+          <p:nvPr/>
+        </p:nvSpPr>
+        <p:spPr>
+          <a:xfrm>
+            <a:off x="1143000" y="6840885"/>
+            <a:ext cx="47625" cy="992386"/>
           </a:xfrm>
           <a:prstGeom prst="rect">
             <a:avLst/>
@@ -18861,98 +19660,157 @@
           <a:solidFill>
             <a:srgbClr val="C0623F"/>
           </a:solidFill>
-          <a:ln>
-            <a:noFill/>
-          </a:ln>
-        </p:spPr>
-        <p:style>
-          <a:lnRef idx="1">
-            <a:schemeClr val="accent1"/>
-          </a:lnRef>
-          <a:fillRef idx="3">
-            <a:schemeClr val="accent1"/>
-          </a:fillRef>
-          <a:effectRef idx="2">
-            <a:schemeClr val="accent1"/>
-          </a:effectRef>
-          <a:fontRef idx="minor">
-            <a:schemeClr val="lt1"/>
-          </a:fontRef>
-        </p:style>
-        <p:txBody>
-          <a:bodyPr rtlCol="0" anchor="ctr"/>
-          <a:lstStyle/>
-          <a:p>
-            <a:pPr algn="ctr"/>
-          </a:p>
-        </p:txBody>
-      </p:sp>
-      <p:sp>
-        <p:nvSpPr>
-          <p:cNvPr id="5" name="TextBox 4"/>
-          <p:cNvSpPr txBox="1"/>
-          <p:nvPr/>
-        </p:nvSpPr>
-        <p:spPr>
-          <a:xfrm>
-            <a:off x="1554480" y="3108960"/>
-            <a:ext cx="15179040" cy="3931920"/>
-          </a:xfrm>
-          <a:prstGeom prst="rect">
-            <a:avLst/>
-          </a:prstGeom>
-          <a:noFill/>
-        </p:spPr>
-        <p:txBody>
-          <a:bodyPr wrap="square" anchor="ctr">
-            <a:normAutofit/>
-          </a:bodyPr>
-          <a:lstStyle/>
-          <a:p>
-            <a:r>
-              <a:rPr sz="5400" b="1">
-                <a:solidFill>
-                  <a:srgbClr val="FFFFFF"/>
-                </a:solidFill>
-                <a:latin typeface="Arial"/>
-              </a:rPr>
-              <a:t>Un avocat a cité six jugements à l'appui de son dossier. Aucun n'existait.</a:t>
-            </a:r>
-          </a:p>
-        </p:txBody>
-      </p:sp>
-      <p:sp>
-        <p:nvSpPr>
-          <p:cNvPr id="6" name="TextBox 5"/>
-          <p:cNvSpPr txBox="1"/>
-          <p:nvPr/>
-        </p:nvSpPr>
-        <p:spPr>
-          <a:xfrm>
-            <a:off x="16093440" y="9400032"/>
-            <a:ext cx="1143000" cy="310896"/>
-          </a:xfrm>
-          <a:prstGeom prst="rect">
-            <a:avLst/>
-          </a:prstGeom>
-          <a:noFill/>
-        </p:spPr>
-        <p:txBody>
-          <a:bodyPr wrap="none">
-            <a:spAutoFit/>
-          </a:bodyPr>
-          <a:lstStyle/>
-          <a:p>
-            <a:pPr algn="r"/>
-            <a:r>
-              <a:rPr sz="1100">
-                <a:solidFill>
-                  <a:srgbClr val="F7F2EA"/>
-                </a:solidFill>
-                <a:latin typeface="Arial"/>
+          <a:ln/>
+        </p:spPr>
+      </p:sp>
+      <p:sp>
+        <p:nvSpPr>
+          <p:cNvPr id="9" name="Text 7"/>
+          <p:cNvSpPr/>
+          <p:nvPr/>
+        </p:nvSpPr>
+        <p:spPr>
+          <a:xfrm>
+            <a:off x="1552575" y="7126635"/>
+            <a:ext cx="13420859" cy="458986"/>
+          </a:xfrm>
+          <a:prstGeom prst="rect">
+            <a:avLst/>
+          </a:prstGeom>
+          <a:noFill/>
+          <a:ln/>
+        </p:spPr>
+        <p:txBody>
+          <a:bodyPr wrap="square" lIns="25400" tIns="25400" rIns="25400" bIns="25400" rtlCol="0" anchor="t">
+            <a:normAutofit fontScale="92500" lnSpcReduction="10000"/>
+          </a:bodyPr>
+          <a:lstStyle/>
+          <a:p>
+            <a:pPr marL="0" indent="0" algn="l">
+              <a:lnSpc>
+                <a:spcPct val="135000"/>
+              </a:lnSpc>
+              <a:buNone/>
+            </a:pPr>
+            <a:r>
+              <a:rPr lang="en-US" sz="2400" dirty="0">
+                <a:solidFill>
+                  <a:srgbClr val="1E2933"/>
+                </a:solidFill>
+                <a:latin typeface="Arial" pitchFamily="34" charset="0"/>
+                <a:ea typeface="Arial" pitchFamily="34" charset="-122"/>
+                <a:cs typeface="Arial" pitchFamily="34" charset="-120"/>
+              </a:rPr>
+              <a:t>L'IA n'avait pas menti : elle avait produit du texte </a:t>
+            </a:r>
+            <a:r>
+              <a:rPr lang="en-US" sz="2400" b="1" dirty="0">
+                <a:solidFill>
+                  <a:srgbClr val="C0623F"/>
+                </a:solidFill>
+                <a:latin typeface="Arial" pitchFamily="34" charset="0"/>
+                <a:ea typeface="Arial" pitchFamily="34" charset="-122"/>
+                <a:cs typeface="Arial" pitchFamily="34" charset="-120"/>
+              </a:rPr>
+              <a:t>plausible</a:t>
+            </a:r>
+            <a:r>
+              <a:rPr lang="en-US" sz="2400" dirty="0">
+                <a:solidFill>
+                  <a:srgbClr val="1E2933"/>
+                </a:solidFill>
+                <a:latin typeface="Arial" pitchFamily="34" charset="0"/>
+                <a:ea typeface="Arial" pitchFamily="34" charset="-122"/>
+                <a:cs typeface="Arial" pitchFamily="34" charset="-120"/>
+              </a:rPr>
+              <a:t>. Vérifier, c'est notre métier.</a:t>
+            </a:r>
+            <a:endParaRPr lang="en-US" sz="2400" dirty="0"/>
+          </a:p>
+        </p:txBody>
+      </p:sp>
+      <p:sp>
+        <p:nvSpPr>
+          <p:cNvPr id="10" name="Shape 8"/>
+          <p:cNvSpPr/>
+          <p:nvPr/>
+        </p:nvSpPr>
+        <p:spPr>
+          <a:xfrm>
+            <a:off x="1143000" y="9020175"/>
+            <a:ext cx="16002000" cy="9525"/>
+          </a:xfrm>
+          <a:prstGeom prst="rect">
+            <a:avLst/>
+          </a:prstGeom>
+          <a:solidFill>
+            <a:srgbClr val="D5DBDF"/>
+          </a:solidFill>
+          <a:ln/>
+        </p:spPr>
+      </p:sp>
+      <p:pic>
+        <p:nvPicPr>
+          <p:cNvPr id="11" name="Image 0" descr="preencoded.png"/>
+          <p:cNvPicPr>
+            <a:picLocks noChangeAspect="1"/>
+          </p:cNvPicPr>
+          <p:nvPr/>
+        </p:nvPicPr>
+        <p:blipFill>
+          <a:blip r:embed="rId3"/>
+          <a:stretch>
+            <a:fillRect/>
+          </a:stretch>
+        </p:blipFill>
+        <p:spPr>
+          <a:xfrm>
+            <a:off x="1143000" y="9239250"/>
+            <a:ext cx="393204" cy="590550"/>
+          </a:xfrm>
+          <a:prstGeom prst="rect">
+            <a:avLst/>
+          </a:prstGeom>
+        </p:spPr>
+      </p:pic>
+      <p:sp>
+        <p:nvSpPr>
+          <p:cNvPr id="12" name="Text 9"/>
+          <p:cNvSpPr/>
+          <p:nvPr/>
+        </p:nvSpPr>
+        <p:spPr>
+          <a:xfrm>
+            <a:off x="16234023" y="9396413"/>
+            <a:ext cx="987177" cy="314325"/>
+          </a:xfrm>
+          <a:prstGeom prst="rect">
+            <a:avLst/>
+          </a:prstGeom>
+          <a:noFill/>
+          <a:ln/>
+        </p:spPr>
+        <p:txBody>
+          <a:bodyPr wrap="square" lIns="25400" tIns="25400" rIns="25400" bIns="25400" rtlCol="0" anchor="t">
+            <a:normAutofit lnSpcReduction="10000"/>
+          </a:bodyPr>
+          <a:lstStyle/>
+          <a:p>
+            <a:pPr marL="0" indent="0" algn="l">
+              <a:buNone/>
+            </a:pPr>
+            <a:r>
+              <a:rPr lang="en-US" sz="1800" kern="0" spc="150" dirty="0">
+                <a:solidFill>
+                  <a:srgbClr val="8A9097"/>
+                </a:solidFill>
+                <a:latin typeface="Arial" pitchFamily="34" charset="0"/>
+                <a:ea typeface="Arial" pitchFamily="34" charset="-122"/>
+                <a:cs typeface="Arial" pitchFamily="34" charset="-120"/>
               </a:rPr>
               <a:t>09 / 23</a:t>
             </a:r>
+            <a:endParaRPr lang="en-US" sz="1800" dirty="0"/>
           </a:p>
         </p:txBody>
       </p:sp>

</xml_diff>